<commit_message>
Fix code-slide layout overflow in Lab 06 memory deck
Re-render the three "How the code works" slides at 12pt with exact
14.5pt line spacing and a taller code panel so the longest snippet
(19 lines) fits well inside the panel and clears the footer band.
Also correct the recall declaration to `Recall? recall` to match
Program.cs.

Co-authored-by: Copilot <223556219+Copilot@users.noreply.github.com>
Copilot-Session: 38d5a62b-2cf9-48df-bf31-171a424c5641
</commit_message>
<xml_diff>
--- a/labs/lab06-multi-agent/presentation/Lab06-Agent-Memory-Strategies.pptx
+++ b/labs/lab06-multi-agent/presentation/Lab06-Agent-Memory-Strategies.pptx
@@ -6171,8 +6171,8 @@
         </p:nvSpPr>
         <p:spPr>
           <a:xfrm>
-            <a:off x="502920" y="1371600"/>
-            <a:ext cx="10332720" cy="4160520"/>
+            <a:off x="502920" y="1298448"/>
+            <a:ext cx="10332720" cy="4709160"/>
           </a:xfrm>
           <a:prstGeom prst="roundRect">
             <a:avLst/>
@@ -6215,7 +6215,7 @@
         </p:nvSpPr>
         <p:spPr>
           <a:xfrm>
-            <a:off x="758952" y="1463040"/>
+            <a:off x="758952" y="1389888"/>
             <a:ext cx="9875520" cy="274320"/>
           </a:xfrm>
           <a:prstGeom prst="rect">
@@ -6250,8 +6250,8 @@
         </p:nvSpPr>
         <p:spPr>
           <a:xfrm>
-            <a:off x="758952" y="1828800"/>
-            <a:ext cx="9875520" cy="3566160"/>
+            <a:off x="758952" y="1737360"/>
+            <a:ext cx="9875520" cy="4142232"/>
           </a:xfrm>
           <a:prstGeom prst="rect">
             <a:avLst/>
@@ -6265,12 +6265,15 @@
           <a:lstStyle/>
           <a:p>
             <a:pPr algn="l">
-              <a:spcAft>
-                <a:spcPts val="200"/>
-              </a:spcAft>
-            </a:pPr>
-            <a:r>
-              <a:rPr sz="1300" b="0" i="0">
+              <a:lnSpc>
+                <a:spcPts val="1450"/>
+              </a:lnSpc>
+              <a:spcAft>
+                <a:spcPts val="0"/>
+              </a:spcAft>
+            </a:pPr>
+            <a:r>
+              <a:rPr sz="1200" b="0" i="0">
                 <a:solidFill>
                   <a:srgbClr val="6A9955"/>
                 </a:solidFill>
@@ -6281,12 +6284,15 @@
           </a:p>
           <a:p>
             <a:pPr algn="l">
-              <a:spcAft>
-                <a:spcPts val="200"/>
-              </a:spcAft>
-            </a:pPr>
-            <a:r>
-              <a:rPr sz="1300" b="0" i="0">
+              <a:lnSpc>
+                <a:spcPts val="1450"/>
+              </a:lnSpc>
+              <a:spcAft>
+                <a:spcPts val="0"/>
+              </a:spcAft>
+            </a:pPr>
+            <a:r>
+              <a:rPr sz="1200" b="0" i="0">
                 <a:solidFill>
                   <a:srgbClr val="DCDCDC"/>
                 </a:solidFill>
@@ -6297,12 +6303,15 @@
           </a:p>
           <a:p>
             <a:pPr algn="l">
-              <a:spcAft>
-                <a:spcPts val="200"/>
-              </a:spcAft>
-            </a:pPr>
-            <a:r>
-              <a:rPr sz="1300" b="0" i="0">
+              <a:lnSpc>
+                <a:spcPts val="1450"/>
+              </a:lnSpc>
+              <a:spcAft>
+                <a:spcPts val="0"/>
+              </a:spcAft>
+            </a:pPr>
+            <a:r>
+              <a:rPr sz="1200" b="0" i="0">
                 <a:solidFill>
                   <a:srgbClr val="DCDCDC"/>
                 </a:solidFill>
@@ -6313,12 +6322,15 @@
           </a:p>
           <a:p>
             <a:pPr algn="l">
-              <a:spcAft>
-                <a:spcPts val="200"/>
-              </a:spcAft>
-            </a:pPr>
-            <a:r>
-              <a:rPr sz="1300" b="0" i="0">
+              <a:lnSpc>
+                <a:spcPts val="1450"/>
+              </a:lnSpc>
+              <a:spcAft>
+                <a:spcPts val="0"/>
+              </a:spcAft>
+            </a:pPr>
+            <a:r>
+              <a:rPr sz="1200" b="0" i="0">
                 <a:solidFill>
                   <a:srgbClr val="DCDCDC"/>
                 </a:solidFill>
@@ -6329,12 +6341,15 @@
           </a:p>
           <a:p>
             <a:pPr algn="l">
-              <a:spcAft>
-                <a:spcPts val="200"/>
-              </a:spcAft>
-            </a:pPr>
-            <a:r>
-              <a:rPr sz="1300" b="0" i="0">
+              <a:lnSpc>
+                <a:spcPts val="1450"/>
+              </a:lnSpc>
+              <a:spcAft>
+                <a:spcPts val="0"/>
+              </a:spcAft>
+            </a:pPr>
+            <a:r>
+              <a:rPr sz="1200" b="0" i="0">
                 <a:solidFill>
                   <a:srgbClr val="DCDCDC"/>
                 </a:solidFill>
@@ -6345,12 +6360,15 @@
           </a:p>
           <a:p>
             <a:pPr algn="l">
-              <a:spcAft>
-                <a:spcPts val="200"/>
-              </a:spcAft>
-            </a:pPr>
-            <a:r>
-              <a:rPr sz="1300" b="1" i="0">
+              <a:lnSpc>
+                <a:spcPts val="1450"/>
+              </a:lnSpc>
+              <a:spcAft>
+                <a:spcPts val="0"/>
+              </a:spcAft>
+            </a:pPr>
+            <a:r>
+              <a:rPr sz="1200" b="1" i="0">
                 <a:solidFill>
                   <a:srgbClr val="9CDCFE"/>
                 </a:solidFill>
@@ -6361,12 +6379,15 @@
           </a:p>
           <a:p>
             <a:pPr algn="l">
-              <a:spcAft>
-                <a:spcPts val="200"/>
-              </a:spcAft>
-            </a:pPr>
-            <a:r>
-              <a:rPr sz="1300" b="0" i="0">
+              <a:lnSpc>
+                <a:spcPts val="1450"/>
+              </a:lnSpc>
+              <a:spcAft>
+                <a:spcPts val="0"/>
+              </a:spcAft>
+            </a:pPr>
+            <a:r>
+              <a:rPr sz="1200" b="0" i="0">
                 <a:solidFill>
                   <a:srgbClr val="DCDCDC"/>
                 </a:solidFill>
@@ -6377,8 +6398,11 @@
           </a:p>
           <a:p>
             <a:pPr algn="l">
-              <a:spcAft>
-                <a:spcPts val="200"/>
+              <a:lnSpc>
+                <a:spcPts val="1450"/>
+              </a:lnSpc>
+              <a:spcAft>
+                <a:spcPts val="0"/>
               </a:spcAft>
             </a:pPr>
             <a:r>
@@ -6393,12 +6417,15 @@
           </a:p>
           <a:p>
             <a:pPr algn="l">
-              <a:spcAft>
-                <a:spcPts val="200"/>
-              </a:spcAft>
-            </a:pPr>
-            <a:r>
-              <a:rPr sz="1300" b="0" i="0">
+              <a:lnSpc>
+                <a:spcPts val="1450"/>
+              </a:lnSpc>
+              <a:spcAft>
+                <a:spcPts val="0"/>
+              </a:spcAft>
+            </a:pPr>
+            <a:r>
+              <a:rPr sz="1200" b="0" i="0">
                 <a:solidFill>
                   <a:srgbClr val="6A9955"/>
                 </a:solidFill>
@@ -6409,12 +6436,15 @@
           </a:p>
           <a:p>
             <a:pPr algn="l">
-              <a:spcAft>
-                <a:spcPts val="200"/>
-              </a:spcAft>
-            </a:pPr>
-            <a:r>
-              <a:rPr sz="1300" b="0" i="0">
+              <a:lnSpc>
+                <a:spcPts val="1450"/>
+              </a:lnSpc>
+              <a:spcAft>
+                <a:spcPts val="0"/>
+              </a:spcAft>
+            </a:pPr>
+            <a:r>
+              <a:rPr sz="1200" b="0" i="0">
                 <a:solidFill>
                   <a:srgbClr val="DCDCDC"/>
                 </a:solidFill>
@@ -6425,12 +6455,15 @@
           </a:p>
           <a:p>
             <a:pPr algn="l">
-              <a:spcAft>
-                <a:spcPts val="200"/>
-              </a:spcAft>
-            </a:pPr>
-            <a:r>
-              <a:rPr sz="1300" b="0" i="0">
+              <a:lnSpc>
+                <a:spcPts val="1450"/>
+              </a:lnSpc>
+              <a:spcAft>
+                <a:spcPts val="0"/>
+              </a:spcAft>
+            </a:pPr>
+            <a:r>
+              <a:rPr sz="1200" b="0" i="0">
                 <a:solidFill>
                   <a:srgbClr val="DCDCDC"/>
                 </a:solidFill>
@@ -6441,12 +6474,15 @@
           </a:p>
           <a:p>
             <a:pPr algn="l">
-              <a:spcAft>
-                <a:spcPts val="200"/>
-              </a:spcAft>
-            </a:pPr>
-            <a:r>
-              <a:rPr sz="1300" b="0" i="0">
+              <a:lnSpc>
+                <a:spcPts val="1450"/>
+              </a:lnSpc>
+              <a:spcAft>
+                <a:spcPts val="0"/>
+              </a:spcAft>
+            </a:pPr>
+            <a:r>
+              <a:rPr sz="1200" b="0" i="0">
                 <a:solidFill>
                   <a:srgbClr val="DCDCDC"/>
                 </a:solidFill>
@@ -6457,12 +6493,15 @@
           </a:p>
           <a:p>
             <a:pPr algn="l">
-              <a:spcAft>
-                <a:spcPts val="200"/>
-              </a:spcAft>
-            </a:pPr>
-            <a:r>
-              <a:rPr sz="1300" b="0" i="0">
+              <a:lnSpc>
+                <a:spcPts val="1450"/>
+              </a:lnSpc>
+              <a:spcAft>
+                <a:spcPts val="0"/>
+              </a:spcAft>
+            </a:pPr>
+            <a:r>
+              <a:rPr sz="1200" b="0" i="0">
                 <a:solidFill>
                   <a:srgbClr val="DCDCDC"/>
                 </a:solidFill>
@@ -6473,12 +6512,15 @@
           </a:p>
           <a:p>
             <a:pPr algn="l">
-              <a:spcAft>
-                <a:spcPts val="200"/>
-              </a:spcAft>
-            </a:pPr>
-            <a:r>
-              <a:rPr sz="1300" b="0" i="0">
+              <a:lnSpc>
+                <a:spcPts val="1450"/>
+              </a:lnSpc>
+              <a:spcAft>
+                <a:spcPts val="0"/>
+              </a:spcAft>
+            </a:pPr>
+            <a:r>
+              <a:rPr sz="1200" b="0" i="0">
                 <a:solidFill>
                   <a:srgbClr val="DCDCDC"/>
                 </a:solidFill>
@@ -6489,12 +6531,15 @@
           </a:p>
           <a:p>
             <a:pPr algn="l">
-              <a:spcAft>
-                <a:spcPts val="200"/>
-              </a:spcAft>
-            </a:pPr>
-            <a:r>
-              <a:rPr sz="1300" b="1" i="0">
+              <a:lnSpc>
+                <a:spcPts val="1450"/>
+              </a:lnSpc>
+              <a:spcAft>
+                <a:spcPts val="0"/>
+              </a:spcAft>
+            </a:pPr>
+            <a:r>
+              <a:rPr sz="1200" b="1" i="0">
                 <a:solidFill>
                   <a:srgbClr val="9CDCFE"/>
                 </a:solidFill>
@@ -6505,12 +6550,15 @@
           </a:p>
           <a:p>
             <a:pPr algn="l">
-              <a:spcAft>
-                <a:spcPts val="200"/>
-              </a:spcAft>
-            </a:pPr>
-            <a:r>
-              <a:rPr sz="1300" b="0" i="0">
+              <a:lnSpc>
+                <a:spcPts val="1450"/>
+              </a:lnSpc>
+              <a:spcAft>
+                <a:spcPts val="0"/>
+              </a:spcAft>
+            </a:pPr>
+            <a:r>
+              <a:rPr sz="1200" b="0" i="0">
                 <a:solidFill>
                   <a:srgbClr val="DCDCDC"/>
                 </a:solidFill>
@@ -6521,12 +6569,15 @@
           </a:p>
           <a:p>
             <a:pPr algn="l">
-              <a:spcAft>
-                <a:spcPts val="200"/>
-              </a:spcAft>
-            </a:pPr>
-            <a:r>
-              <a:rPr sz="1300" b="0" i="0">
+              <a:lnSpc>
+                <a:spcPts val="1450"/>
+              </a:lnSpc>
+              <a:spcAft>
+                <a:spcPts val="0"/>
+              </a:spcAft>
+            </a:pPr>
+            <a:r>
+              <a:rPr sz="1200" b="0" i="0">
                 <a:solidFill>
                   <a:srgbClr val="DCDCDC"/>
                 </a:solidFill>
@@ -6537,12 +6588,15 @@
           </a:p>
           <a:p>
             <a:pPr algn="l">
-              <a:spcAft>
-                <a:spcPts val="200"/>
-              </a:spcAft>
-            </a:pPr>
-            <a:r>
-              <a:rPr sz="1300" b="1" i="0">
+              <a:lnSpc>
+                <a:spcPts val="1450"/>
+              </a:lnSpc>
+              <a:spcAft>
+                <a:spcPts val="0"/>
+              </a:spcAft>
+            </a:pPr>
+            <a:r>
+              <a:rPr sz="1200" b="1" i="0">
                 <a:solidFill>
                   <a:srgbClr val="9CDCFE"/>
                 </a:solidFill>
@@ -6553,12 +6607,15 @@
           </a:p>
           <a:p>
             <a:pPr algn="l">
-              <a:spcAft>
-                <a:spcPts val="200"/>
-              </a:spcAft>
-            </a:pPr>
-            <a:r>
-              <a:rPr sz="1300" b="0" i="0">
+              <a:lnSpc>
+                <a:spcPts val="1450"/>
+              </a:lnSpc>
+              <a:spcAft>
+                <a:spcPts val="0"/>
+              </a:spcAft>
+            </a:pPr>
+            <a:r>
+              <a:rPr sz="1200" b="0" i="0">
                 <a:solidFill>
                   <a:srgbClr val="DCDCDC"/>
                 </a:solidFill>
@@ -6577,7 +6634,7 @@
         </p:nvSpPr>
         <p:spPr>
           <a:xfrm>
-            <a:off x="502920" y="5650992"/>
+            <a:off x="502920" y="6089904"/>
             <a:ext cx="10332720" cy="274320"/>
           </a:xfrm>
           <a:prstGeom prst="rect">
@@ -6902,8 +6959,8 @@
         </p:nvSpPr>
         <p:spPr>
           <a:xfrm>
-            <a:off x="502920" y="1371600"/>
-            <a:ext cx="10332720" cy="4160520"/>
+            <a:off x="502920" y="1298448"/>
+            <a:ext cx="10332720" cy="4709160"/>
           </a:xfrm>
           <a:prstGeom prst="roundRect">
             <a:avLst/>
@@ -6946,7 +7003,7 @@
         </p:nvSpPr>
         <p:spPr>
           <a:xfrm>
-            <a:off x="758952" y="1463040"/>
+            <a:off x="758952" y="1389888"/>
             <a:ext cx="9875520" cy="274320"/>
           </a:xfrm>
           <a:prstGeom prst="rect">
@@ -6981,8 +7038,8 @@
         </p:nvSpPr>
         <p:spPr>
           <a:xfrm>
-            <a:off x="758952" y="1828800"/>
-            <a:ext cx="9875520" cy="3566160"/>
+            <a:off x="758952" y="1737360"/>
+            <a:ext cx="9875520" cy="4142232"/>
           </a:xfrm>
           <a:prstGeom prst="rect">
             <a:avLst/>
@@ -6996,12 +7053,15 @@
           <a:lstStyle/>
           <a:p>
             <a:pPr algn="l">
-              <a:spcAft>
-                <a:spcPts val="200"/>
-              </a:spcAft>
-            </a:pPr>
-            <a:r>
-              <a:rPr sz="1300" b="0" i="0">
+              <a:lnSpc>
+                <a:spcPts val="1450"/>
+              </a:lnSpc>
+              <a:spcAft>
+                <a:spcPts val="0"/>
+              </a:spcAft>
+            </a:pPr>
+            <a:r>
+              <a:rPr sz="1200" b="0" i="0">
                 <a:solidFill>
                   <a:srgbClr val="6A9955"/>
                 </a:solidFill>
@@ -7012,12 +7072,15 @@
           </a:p>
           <a:p>
             <a:pPr algn="l">
-              <a:spcAft>
-                <a:spcPts val="200"/>
-              </a:spcAft>
-            </a:pPr>
-            <a:r>
-              <a:rPr sz="1300" b="0" i="0">
+              <a:lnSpc>
+                <a:spcPts val="1450"/>
+              </a:lnSpc>
+              <a:spcAft>
+                <a:spcPts val="0"/>
+              </a:spcAft>
+            </a:pPr>
+            <a:r>
+              <a:rPr sz="1200" b="0" i="0">
                 <a:solidFill>
                   <a:srgbClr val="DCDCDC"/>
                 </a:solidFill>
@@ -7028,12 +7091,15 @@
           </a:p>
           <a:p>
             <a:pPr algn="l">
-              <a:spcAft>
-                <a:spcPts val="200"/>
-              </a:spcAft>
-            </a:pPr>
-            <a:r>
-              <a:rPr sz="1300" b="0" i="0">
+              <a:lnSpc>
+                <a:spcPts val="1450"/>
+              </a:lnSpc>
+              <a:spcAft>
+                <a:spcPts val="0"/>
+              </a:spcAft>
+            </a:pPr>
+            <a:r>
+              <a:rPr sz="1200" b="0" i="0">
                 <a:solidFill>
                   <a:srgbClr val="DCDCDC"/>
                 </a:solidFill>
@@ -7044,12 +7110,15 @@
           </a:p>
           <a:p>
             <a:pPr algn="l">
-              <a:spcAft>
-                <a:spcPts val="200"/>
-              </a:spcAft>
-            </a:pPr>
-            <a:r>
-              <a:rPr sz="1300" b="0" i="0">
+              <a:lnSpc>
+                <a:spcPts val="1450"/>
+              </a:lnSpc>
+              <a:spcAft>
+                <a:spcPts val="0"/>
+              </a:spcAft>
+            </a:pPr>
+            <a:r>
+              <a:rPr sz="1200" b="0" i="0">
                 <a:solidFill>
                   <a:srgbClr val="DCDCDC"/>
                 </a:solidFill>
@@ -7060,12 +7129,15 @@
           </a:p>
           <a:p>
             <a:pPr algn="l">
-              <a:spcAft>
-                <a:spcPts val="200"/>
-              </a:spcAft>
-            </a:pPr>
-            <a:r>
-              <a:rPr sz="1300" b="0" i="0">
+              <a:lnSpc>
+                <a:spcPts val="1450"/>
+              </a:lnSpc>
+              <a:spcAft>
+                <a:spcPts val="0"/>
+              </a:spcAft>
+            </a:pPr>
+            <a:r>
+              <a:rPr sz="1200" b="0" i="0">
                 <a:solidFill>
                   <a:srgbClr val="DCDCDC"/>
                 </a:solidFill>
@@ -7076,12 +7148,15 @@
           </a:p>
           <a:p>
             <a:pPr algn="l">
-              <a:spcAft>
-                <a:spcPts val="200"/>
-              </a:spcAft>
-            </a:pPr>
-            <a:r>
-              <a:rPr sz="1300" b="0" i="0">
+              <a:lnSpc>
+                <a:spcPts val="1450"/>
+              </a:lnSpc>
+              <a:spcAft>
+                <a:spcPts val="0"/>
+              </a:spcAft>
+            </a:pPr>
+            <a:r>
+              <a:rPr sz="1200" b="0" i="0">
                 <a:solidFill>
                   <a:srgbClr val="DCDCDC"/>
                 </a:solidFill>
@@ -7092,12 +7167,15 @@
           </a:p>
           <a:p>
             <a:pPr algn="l">
-              <a:spcAft>
-                <a:spcPts val="200"/>
-              </a:spcAft>
-            </a:pPr>
-            <a:r>
-              <a:rPr sz="1300" b="1" i="0">
+              <a:lnSpc>
+                <a:spcPts val="1450"/>
+              </a:lnSpc>
+              <a:spcAft>
+                <a:spcPts val="0"/>
+              </a:spcAft>
+            </a:pPr>
+            <a:r>
+              <a:rPr sz="1200" b="1" i="0">
                 <a:solidFill>
                   <a:srgbClr val="9CDCFE"/>
                 </a:solidFill>
@@ -7108,12 +7186,15 @@
           </a:p>
           <a:p>
             <a:pPr algn="l">
-              <a:spcAft>
-                <a:spcPts val="200"/>
-              </a:spcAft>
-            </a:pPr>
-            <a:r>
-              <a:rPr sz="1300" b="0" i="0">
+              <a:lnSpc>
+                <a:spcPts val="1450"/>
+              </a:lnSpc>
+              <a:spcAft>
+                <a:spcPts val="0"/>
+              </a:spcAft>
+            </a:pPr>
+            <a:r>
+              <a:rPr sz="1200" b="0" i="0">
                 <a:solidFill>
                   <a:srgbClr val="DCDCDC"/>
                 </a:solidFill>
@@ -7124,8 +7205,11 @@
           </a:p>
           <a:p>
             <a:pPr algn="l">
-              <a:spcAft>
-                <a:spcPts val="200"/>
+              <a:lnSpc>
+                <a:spcPts val="1450"/>
+              </a:lnSpc>
+              <a:spcAft>
+                <a:spcPts val="0"/>
               </a:spcAft>
             </a:pPr>
             <a:r>
@@ -7140,12 +7224,15 @@
           </a:p>
           <a:p>
             <a:pPr algn="l">
-              <a:spcAft>
-                <a:spcPts val="200"/>
-              </a:spcAft>
-            </a:pPr>
-            <a:r>
-              <a:rPr sz="1300" b="0" i="0">
+              <a:lnSpc>
+                <a:spcPts val="1450"/>
+              </a:lnSpc>
+              <a:spcAft>
+                <a:spcPts val="0"/>
+              </a:spcAft>
+            </a:pPr>
+            <a:r>
+              <a:rPr sz="1200" b="0" i="0">
                 <a:solidFill>
                   <a:srgbClr val="6A9955"/>
                 </a:solidFill>
@@ -7156,28 +7243,34 @@
           </a:p>
           <a:p>
             <a:pPr algn="l">
-              <a:spcAft>
-                <a:spcPts val="200"/>
-              </a:spcAft>
-            </a:pPr>
-            <a:r>
-              <a:rPr sz="1300" b="0" i="0">
+              <a:lnSpc>
+                <a:spcPts val="1450"/>
+              </a:lnSpc>
+              <a:spcAft>
+                <a:spcPts val="0"/>
+              </a:spcAft>
+            </a:pPr>
+            <a:r>
+              <a:rPr sz="1200" b="0" i="0">
                 <a:solidFill>
                   <a:srgbClr val="DCDCDC"/>
                 </a:solidFill>
                 <a:latin typeface="Consolas"/>
               </a:rPr>
-              <a:t>var recall = memory is null ? null</a:t>
-            </a:r>
-          </a:p>
-          <a:p>
-            <a:pPr algn="l">
-              <a:spcAft>
-                <a:spcPts val="200"/>
-              </a:spcAft>
-            </a:pPr>
-            <a:r>
-              <a:rPr sz="1300" b="0" i="0">
+              <a:t>Recall? recall = memory is null ? null</a:t>
+            </a:r>
+          </a:p>
+          <a:p>
+            <a:pPr algn="l">
+              <a:lnSpc>
+                <a:spcPts val="1450"/>
+              </a:lnSpc>
+              <a:spcAft>
+                <a:spcPts val="0"/>
+              </a:spcAft>
+            </a:pPr>
+            <a:r>
+              <a:rPr sz="1200" b="0" i="0">
                 <a:solidFill>
                   <a:srgbClr val="DCDCDC"/>
                 </a:solidFill>
@@ -7188,12 +7281,15 @@
           </a:p>
           <a:p>
             <a:pPr algn="l">
-              <a:spcAft>
-                <a:spcPts val="200"/>
-              </a:spcAft>
-            </a:pPr>
-            <a:r>
-              <a:rPr sz="1300" b="0" i="0">
+              <a:lnSpc>
+                <a:spcPts val="1450"/>
+              </a:lnSpc>
+              <a:spcAft>
+                <a:spcPts val="0"/>
+              </a:spcAft>
+            </a:pPr>
+            <a:r>
+              <a:rPr sz="1200" b="0" i="0">
                 <a:solidFill>
                   <a:srgbClr val="DCDCDC"/>
                 </a:solidFill>
@@ -7204,12 +7300,15 @@
           </a:p>
           <a:p>
             <a:pPr algn="l">
-              <a:spcAft>
-                <a:spcPts val="200"/>
-              </a:spcAft>
-            </a:pPr>
-            <a:r>
-              <a:rPr sz="1300" b="1" i="0">
+              <a:lnSpc>
+                <a:spcPts val="1450"/>
+              </a:lnSpc>
+              <a:spcAft>
+                <a:spcPts val="0"/>
+              </a:spcAft>
+            </a:pPr>
+            <a:r>
+              <a:rPr sz="1200" b="1" i="0">
                 <a:solidFill>
                   <a:srgbClr val="9CDCFE"/>
                 </a:solidFill>
@@ -7220,8 +7319,11 @@
           </a:p>
           <a:p>
             <a:pPr algn="l">
-              <a:spcAft>
-                <a:spcPts val="200"/>
+              <a:lnSpc>
+                <a:spcPts val="1450"/>
+              </a:lnSpc>
+              <a:spcAft>
+                <a:spcPts val="0"/>
               </a:spcAft>
             </a:pPr>
             <a:r>
@@ -7236,12 +7338,15 @@
           </a:p>
           <a:p>
             <a:pPr algn="l">
-              <a:spcAft>
-                <a:spcPts val="200"/>
-              </a:spcAft>
-            </a:pPr>
-            <a:r>
-              <a:rPr sz="1300" b="0" i="0">
+              <a:lnSpc>
+                <a:spcPts val="1450"/>
+              </a:lnSpc>
+              <a:spcAft>
+                <a:spcPts val="0"/>
+              </a:spcAft>
+            </a:pPr>
+            <a:r>
+              <a:rPr sz="1200" b="0" i="0">
                 <a:solidFill>
                   <a:srgbClr val="6A9955"/>
                 </a:solidFill>
@@ -7252,12 +7357,15 @@
           </a:p>
           <a:p>
             <a:pPr algn="l">
-              <a:spcAft>
-                <a:spcPts val="200"/>
-              </a:spcAft>
-            </a:pPr>
-            <a:r>
-              <a:rPr sz="1300" b="1" i="0">
+              <a:lnSpc>
+                <a:spcPts val="1450"/>
+              </a:lnSpc>
+              <a:spcAft>
+                <a:spcPts val="0"/>
+              </a:spcAft>
+            </a:pPr>
+            <a:r>
+              <a:rPr sz="1200" b="1" i="0">
                 <a:solidFill>
                   <a:srgbClr val="9CDCFE"/>
                 </a:solidFill>
@@ -7276,7 +7384,7 @@
         </p:nvSpPr>
         <p:spPr>
           <a:xfrm>
-            <a:off x="502920" y="5650992"/>
+            <a:off x="502920" y="6089904"/>
             <a:ext cx="10332720" cy="274320"/>
           </a:xfrm>
           <a:prstGeom prst="rect">
@@ -7601,8 +7709,8 @@
         </p:nvSpPr>
         <p:spPr>
           <a:xfrm>
-            <a:off x="502920" y="1371600"/>
-            <a:ext cx="10332720" cy="4160520"/>
+            <a:off x="502920" y="1298448"/>
+            <a:ext cx="10332720" cy="4709160"/>
           </a:xfrm>
           <a:prstGeom prst="roundRect">
             <a:avLst/>
@@ -7645,7 +7753,7 @@
         </p:nvSpPr>
         <p:spPr>
           <a:xfrm>
-            <a:off x="758952" y="1463040"/>
+            <a:off x="758952" y="1389888"/>
             <a:ext cx="9875520" cy="274320"/>
           </a:xfrm>
           <a:prstGeom prst="rect">
@@ -7680,8 +7788,8 @@
         </p:nvSpPr>
         <p:spPr>
           <a:xfrm>
-            <a:off x="758952" y="1828800"/>
-            <a:ext cx="9875520" cy="3566160"/>
+            <a:off x="758952" y="1737360"/>
+            <a:ext cx="9875520" cy="4142232"/>
           </a:xfrm>
           <a:prstGeom prst="rect">
             <a:avLst/>
@@ -7695,12 +7803,15 @@
           <a:lstStyle/>
           <a:p>
             <a:pPr algn="l">
-              <a:spcAft>
-                <a:spcPts val="200"/>
-              </a:spcAft>
-            </a:pPr>
-            <a:r>
-              <a:rPr sz="1300" b="0" i="0">
+              <a:lnSpc>
+                <a:spcPts val="1450"/>
+              </a:lnSpc>
+              <a:spcAft>
+                <a:spcPts val="0"/>
+              </a:spcAft>
+            </a:pPr>
+            <a:r>
+              <a:rPr sz="1200" b="0" i="0">
                 <a:solidFill>
                   <a:srgbClr val="6A9955"/>
                 </a:solidFill>
@@ -7711,12 +7822,15 @@
           </a:p>
           <a:p>
             <a:pPr algn="l">
-              <a:spcAft>
-                <a:spcPts val="200"/>
-              </a:spcAft>
-            </a:pPr>
-            <a:r>
-              <a:rPr sz="1300" b="0" i="0">
+              <a:lnSpc>
+                <a:spcPts val="1450"/>
+              </a:lnSpc>
+              <a:spcAft>
+                <a:spcPts val="0"/>
+              </a:spcAft>
+            </a:pPr>
+            <a:r>
+              <a:rPr sz="1200" b="0" i="0">
                 <a:solidFill>
                   <a:srgbClr val="6A9955"/>
                 </a:solidFill>
@@ -7727,12 +7841,15 @@
           </a:p>
           <a:p>
             <a:pPr algn="l">
-              <a:spcAft>
-                <a:spcPts val="200"/>
-              </a:spcAft>
-            </a:pPr>
-            <a:r>
-              <a:rPr sz="1300" b="0" i="0">
+              <a:lnSpc>
+                <a:spcPts val="1450"/>
+              </a:lnSpc>
+              <a:spcAft>
+                <a:spcPts val="0"/>
+              </a:spcAft>
+            </a:pPr>
+            <a:r>
+              <a:rPr sz="1200" b="0" i="0">
                 <a:solidFill>
                   <a:srgbClr val="DCDCDC"/>
                 </a:solidFill>
@@ -7743,12 +7860,15 @@
           </a:p>
           <a:p>
             <a:pPr algn="l">
-              <a:spcAft>
-                <a:spcPts val="200"/>
-              </a:spcAft>
-            </a:pPr>
-            <a:r>
-              <a:rPr sz="1300" b="0" i="0">
+              <a:lnSpc>
+                <a:spcPts val="1450"/>
+              </a:lnSpc>
+              <a:spcAft>
+                <a:spcPts val="0"/>
+              </a:spcAft>
+            </a:pPr>
+            <a:r>
+              <a:rPr sz="1200" b="0" i="0">
                 <a:solidFill>
                   <a:srgbClr val="DCDCDC"/>
                 </a:solidFill>
@@ -7759,12 +7879,15 @@
           </a:p>
           <a:p>
             <a:pPr algn="l">
-              <a:spcAft>
-                <a:spcPts val="200"/>
-              </a:spcAft>
-            </a:pPr>
-            <a:r>
-              <a:rPr sz="1300" b="1" i="0">
+              <a:lnSpc>
+                <a:spcPts val="1450"/>
+              </a:lnSpc>
+              <a:spcAft>
+                <a:spcPts val="0"/>
+              </a:spcAft>
+            </a:pPr>
+            <a:r>
+              <a:rPr sz="1200" b="1" i="0">
                 <a:solidFill>
                   <a:srgbClr val="9CDCFE"/>
                 </a:solidFill>
@@ -7775,8 +7898,11 @@
           </a:p>
           <a:p>
             <a:pPr algn="l">
-              <a:spcAft>
-                <a:spcPts val="200"/>
+              <a:lnSpc>
+                <a:spcPts val="1450"/>
+              </a:lnSpc>
+              <a:spcAft>
+                <a:spcPts val="0"/>
               </a:spcAft>
             </a:pPr>
             <a:r>
@@ -7791,12 +7917,15 @@
           </a:p>
           <a:p>
             <a:pPr algn="l">
-              <a:spcAft>
-                <a:spcPts val="200"/>
-              </a:spcAft>
-            </a:pPr>
-            <a:r>
-              <a:rPr sz="1300" b="0" i="0">
+              <a:lnSpc>
+                <a:spcPts val="1450"/>
+              </a:lnSpc>
+              <a:spcAft>
+                <a:spcPts val="0"/>
+              </a:spcAft>
+            </a:pPr>
+            <a:r>
+              <a:rPr sz="1200" b="0" i="0">
                 <a:solidFill>
                   <a:srgbClr val="DCDCDC"/>
                 </a:solidFill>
@@ -7807,12 +7936,15 @@
           </a:p>
           <a:p>
             <a:pPr algn="l">
-              <a:spcAft>
-                <a:spcPts val="200"/>
-              </a:spcAft>
-            </a:pPr>
-            <a:r>
-              <a:rPr sz="1300" b="0" i="0">
+              <a:lnSpc>
+                <a:spcPts val="1450"/>
+              </a:lnSpc>
+              <a:spcAft>
+                <a:spcPts val="0"/>
+              </a:spcAft>
+            </a:pPr>
+            <a:r>
+              <a:rPr sz="1200" b="0" i="0">
                 <a:solidFill>
                   <a:srgbClr val="DCDCDC"/>
                 </a:solidFill>
@@ -7823,12 +7955,15 @@
           </a:p>
           <a:p>
             <a:pPr algn="l">
-              <a:spcAft>
-                <a:spcPts val="200"/>
-              </a:spcAft>
-            </a:pPr>
-            <a:r>
-              <a:rPr sz="1300" b="0" i="0">
+              <a:lnSpc>
+                <a:spcPts val="1450"/>
+              </a:lnSpc>
+              <a:spcAft>
+                <a:spcPts val="0"/>
+              </a:spcAft>
+            </a:pPr>
+            <a:r>
+              <a:rPr sz="1200" b="0" i="0">
                 <a:solidFill>
                   <a:srgbClr val="DCDCDC"/>
                 </a:solidFill>
@@ -7839,12 +7974,15 @@
           </a:p>
           <a:p>
             <a:pPr algn="l">
-              <a:spcAft>
-                <a:spcPts val="200"/>
-              </a:spcAft>
-            </a:pPr>
-            <a:r>
-              <a:rPr sz="1300" b="0" i="0">
+              <a:lnSpc>
+                <a:spcPts val="1450"/>
+              </a:lnSpc>
+              <a:spcAft>
+                <a:spcPts val="0"/>
+              </a:spcAft>
+            </a:pPr>
+            <a:r>
+              <a:rPr sz="1200" b="0" i="0">
                 <a:solidFill>
                   <a:srgbClr val="DCDCDC"/>
                 </a:solidFill>
@@ -7855,12 +7993,15 @@
           </a:p>
           <a:p>
             <a:pPr algn="l">
-              <a:spcAft>
-                <a:spcPts val="200"/>
-              </a:spcAft>
-            </a:pPr>
-            <a:r>
-              <a:rPr sz="1300" b="1" i="0">
+              <a:lnSpc>
+                <a:spcPts val="1450"/>
+              </a:lnSpc>
+              <a:spcAft>
+                <a:spcPts val="0"/>
+              </a:spcAft>
+            </a:pPr>
+            <a:r>
+              <a:rPr sz="1200" b="1" i="0">
                 <a:solidFill>
                   <a:srgbClr val="9CDCFE"/>
                 </a:solidFill>
@@ -7871,12 +8012,15 @@
           </a:p>
           <a:p>
             <a:pPr algn="l">
-              <a:spcAft>
-                <a:spcPts val="200"/>
-              </a:spcAft>
-            </a:pPr>
-            <a:r>
-              <a:rPr sz="1300" b="0" i="0">
+              <a:lnSpc>
+                <a:spcPts val="1450"/>
+              </a:lnSpc>
+              <a:spcAft>
+                <a:spcPts val="0"/>
+              </a:spcAft>
+            </a:pPr>
+            <a:r>
+              <a:rPr sz="1200" b="0" i="0">
                 <a:solidFill>
                   <a:srgbClr val="DCDCDC"/>
                 </a:solidFill>
@@ -7887,8 +8031,11 @@
           </a:p>
           <a:p>
             <a:pPr algn="l">
-              <a:spcAft>
-                <a:spcPts val="200"/>
+              <a:lnSpc>
+                <a:spcPts val="1450"/>
+              </a:lnSpc>
+              <a:spcAft>
+                <a:spcPts val="0"/>
               </a:spcAft>
             </a:pPr>
             <a:r>
@@ -7903,12 +8050,15 @@
           </a:p>
           <a:p>
             <a:pPr algn="l">
-              <a:spcAft>
-                <a:spcPts val="200"/>
-              </a:spcAft>
-            </a:pPr>
-            <a:r>
-              <a:rPr sz="1300" b="0" i="0">
+              <a:lnSpc>
+                <a:spcPts val="1450"/>
+              </a:lnSpc>
+              <a:spcAft>
+                <a:spcPts val="0"/>
+              </a:spcAft>
+            </a:pPr>
+            <a:r>
+              <a:rPr sz="1200" b="0" i="0">
                 <a:solidFill>
                   <a:srgbClr val="DCDCDC"/>
                 </a:solidFill>
@@ -7919,12 +8069,15 @@
           </a:p>
           <a:p>
             <a:pPr algn="l">
-              <a:spcAft>
-                <a:spcPts val="200"/>
-              </a:spcAft>
-            </a:pPr>
-            <a:r>
-              <a:rPr sz="1300" b="0" i="0">
+              <a:lnSpc>
+                <a:spcPts val="1450"/>
+              </a:lnSpc>
+              <a:spcAft>
+                <a:spcPts val="0"/>
+              </a:spcAft>
+            </a:pPr>
+            <a:r>
+              <a:rPr sz="1200" b="0" i="0">
                 <a:solidFill>
                   <a:srgbClr val="DCDCDC"/>
                 </a:solidFill>
@@ -7935,12 +8088,15 @@
           </a:p>
           <a:p>
             <a:pPr algn="l">
-              <a:spcAft>
-                <a:spcPts val="200"/>
-              </a:spcAft>
-            </a:pPr>
-            <a:r>
-              <a:rPr sz="1300" b="0" i="0">
+              <a:lnSpc>
+                <a:spcPts val="1450"/>
+              </a:lnSpc>
+              <a:spcAft>
+                <a:spcPts val="0"/>
+              </a:spcAft>
+            </a:pPr>
+            <a:r>
+              <a:rPr sz="1200" b="0" i="0">
                 <a:solidFill>
                   <a:srgbClr val="DCDCDC"/>
                 </a:solidFill>
@@ -7951,12 +8107,15 @@
           </a:p>
           <a:p>
             <a:pPr algn="l">
-              <a:spcAft>
-                <a:spcPts val="200"/>
-              </a:spcAft>
-            </a:pPr>
-            <a:r>
-              <a:rPr sz="1300" b="0" i="0">
+              <a:lnSpc>
+                <a:spcPts val="1450"/>
+              </a:lnSpc>
+              <a:spcAft>
+                <a:spcPts val="0"/>
+              </a:spcAft>
+            </a:pPr>
+            <a:r>
+              <a:rPr sz="1200" b="0" i="0">
                 <a:solidFill>
                   <a:srgbClr val="DCDCDC"/>
                 </a:solidFill>
@@ -7967,12 +8126,15 @@
           </a:p>
           <a:p>
             <a:pPr algn="l">
-              <a:spcAft>
-                <a:spcPts val="200"/>
-              </a:spcAft>
-            </a:pPr>
-            <a:r>
-              <a:rPr sz="1300" b="1" i="0">
+              <a:lnSpc>
+                <a:spcPts val="1450"/>
+              </a:lnSpc>
+              <a:spcAft>
+                <a:spcPts val="0"/>
+              </a:spcAft>
+            </a:pPr>
+            <a:r>
+              <a:rPr sz="1200" b="1" i="0">
                 <a:solidFill>
                   <a:srgbClr val="9CDCFE"/>
                 </a:solidFill>
@@ -7991,7 +8153,7 @@
         </p:nvSpPr>
         <p:spPr>
           <a:xfrm>
-            <a:off x="502920" y="5650992"/>
+            <a:off x="502920" y="6089904"/>
             <a:ext cx="10332720" cy="274320"/>
           </a:xfrm>
           <a:prstGeom prst="rect">

</xml_diff>